<commit_message>
Opdater speaker notes i Hans' slides
</commit_message>
<xml_diff>
--- a/praesentation/green-it-hans.pptx
+++ b/praesentation/green-it-hans.pptx
@@ -507,7 +507,7 @@
           <a:p>
             <a:r>
               <a:rPr lang="en-US" dirty="0"/>
-              <a:t>Jeg har opgave 3, 4 og 5. Først Service Value Chain. Så incident og problem management. Og til sidst de fire dimensioner.</a:t>
+              <a:t>Jeg har opgave 3, 4 og 5. Først Service Value Chain, så incident og problem management, og til sidst de fire dimensioner.</a:t>
             </a:r>
             <a:endParaRPr lang="en-US" dirty="0"/>
           </a:p>
@@ -595,8 +595,8 @@
           <a:p>
             <a:r>
               <a:rPr lang="en-US" dirty="0"/>
-              <a:t>Så hvad er Service Value Chain? Det er de seks aktiviteter, der omdanner efterspørgsel og muligheder til værdi. Plan. Improve. Engage. Design og transition. Obtain og build. Deliver og support.
- Aktiviteterne er ikke afdelinger. Engage sker fx både i salg og på de nye kontorer. Vi foreslår, at hver aktivitet får én ansvarlig. Så ryger der ikke opgaver ned mellem byen, fabrikken og Jylland.</a:t>
+              <a:t>Så hvad er en Service Value Chain? Det er de seks aktiviteter, der omdanner efterspørgsel og muligheder til værdi. De hedder plan, improve, engage, design og transition, obtain og build, og deliver og support.
+ Det vigtige er, at aktiviteterne ikke er afdelinger. Engage sker fx både i salg og på de nye kontorer. Og fordi Green-IT er spredt ud på byen, fabrikken og snart Jylland, foreslår vi, at hver aktivitet får én ansvarlig. Så ryger der ikke opgaver ned mellem stederne.</a:t>
             </a:r>
             <a:endParaRPr lang="en-US" dirty="0"/>
           </a:p>
@@ -684,9 +684,9 @@
           <a:p>
             <a:r>
               <a:rPr lang="en-US" dirty="0"/>
-              <a:t>Eksemplet i opgaven er en svineproducent, der vil have staldovervågning. Sælgeren finder ud af, hvad landmanden skal bruge. Det er engage. R&amp;D tilpasser løsningen. Det er design og transition. Fabrikken laver sensorerne. Det er obtain og build. Løsningen testes og overdrages til drift. Det er design og transition igen. Værkstedet installerer. Det er deliver og support. Efter en måned følger sælgeren op. Det er engage igen. Det, vi lærer, gør det hurtigere næste gang. Det er improve.
- Pointen er, at det ikke er et samlebånd. Man bruger aktiviteterne efter behov. Engage og design bruges to gange. Plan bruges slet ikke. En sensorfejl kan gå direkte fra engage til deliver og support.
- Og hver aktivitet bidrager. Engage er der, hvor vi skaber værdien sammen med landmanden. Design og transition tester, før noget kommer i drift. Det beskytter den stabile drift. Deliver og support er der, hvor kunden mærker værdien hver dag. Og improve gør fejl til forbedringer.</a:t>
+              <a:t>For at gøre det konkret har vi i opgaven et eksempel med en svineproducent, der vil have staldovervågning. Først finder sælgeren ud af, hvad landmanden skal bruge. Det er engage. Så tilpasser R&amp;D løsningen, og det er design og transition. Fabrikken laver sensorerne, det er obtain og build. Derefter bliver løsningen testet og overdraget til drift, og det er design og transition igen. Værkstedet installerer, det er deliver og support. Efter en måned følger sælgeren op, så er vi i engage igen. Og det, vi lærer, gør det hurtigere næste gang. Det er improve.
+ Pointen med eksemplet er, at det ikke er et samlebånd. Engage og design bruges to gange, og plan bruges slet ikke, fordi man bruger aktiviteterne efter behov. En sensorfejl kan fx gå direkte fra engage til deliver og support.
+ Og hver aktivitet bidrager til værdien. I engage skaber vi værdien sammen med landmanden. Design og transition tester, før noget kommer i drift, og det beskytter den stabile drift. I deliver og support mærker kunden værdien hver dag. Og improve sørger for, at fejl bliver til forbedringer.</a:t>
             </a:r>
             <a:endParaRPr lang="en-US" dirty="0"/>
           </a:p>
@@ -774,9 +774,9 @@
           <a:p>
             <a:r>
               <a:rPr lang="en-US" dirty="0"/>
-              <a:t>Så kommer vi til opgave 4. Incident management. En incident er en uplanlagt afbrydelse eller forringelse af en service. Altså når noget går ned eller virker dårligere. Formålet er at få det op at køre igen. Hurtigst muligt. Incident management finder ikke årsagen. Det gør problem management.
- Processen har fem trin. Registrer. Prioriter. Diagnosticer. Eskaler. Og løs og luk. Prioriteten sættes ud fra, hvor slemt det er, og hvor meget det haster. Den bestemmer, hvor hurtigt det skal løses. Det står i SLA'en. Eskalering betyder, at sagen går videre. L1 er servicedesken. L2 er specialisterne. L3 er udviklerne i R&amp;D. Landmanden ringer kun ét sted hen. Til servicedesken. Og med et fælles ticketsystem kan alle tre steder se de samme sager.
- Eksemplet er en kvægstald en sommernat. Sensorerne holder op med at sende data. Det er prioritet 1. L2 finder fejlen i gatewayen. Altså boksen, der sender data videre. En tekniker kører ud med en ny. Imens tjekker landmanden selv dyrene. Det er workarounden. En midlertidig løsning. Hvis det rammer mange stalde, er det en major incident. Så får den sin egen leder.</a:t>
+              <a:t>Det leder os over til opgave 4, for hvad gør man, når noget alligevel går galt? Det er incident management. En incident er en uplanlagt afbrydelse eller forringelse af en service, altså når noget går ned eller virker dårligere. Formålet er at få det op at køre igen hurtigst muligt. Incident management finder ikke årsagen. Det gør problem management, som jeg kommer til bagefter.
+ Processen har fem trin: registrer, prioriter, diagnosticer, eskaler, og løs og luk. Prioriteten sættes ud fra, hvor slemt det er, og hvor meget det haster, og den bestemmer, hvor hurtigt det skal løses ifølge SLA'en. Hvis servicedesken ikke selv kan løse det, eskalerer de. L1 er servicedesken, L2 er specialisterne, og L3 er udviklerne i R&amp;D. For Green-IT er det vigtigt, at landmanden kun ringer ét sted hen, nemlig servicedesken, og at et fælles ticketsystem gør, at alle tre steder ser de samme sager.
+ Vores eksempel er en kvægstald en sommernat, hvor sensorerne holder op med at sende data. Det er prioritet 1, fordi dyrene kan tage skade. L2 finder fejlen i gatewayen, altså boksen, der sender data videre, og en tekniker kører ud med en ny. Imens tjekker landmanden selv dyrene. Det er workarounden, en midlertidig løsning. Og hvis det rammer mange stalde på én gang, er det en major incident, som får sin egen leder.</a:t>
             </a:r>
             <a:endParaRPr lang="en-US" dirty="0"/>
           </a:p>
@@ -864,10 +864,10 @@
           <a:p>
             <a:r>
               <a:rPr lang="en-US" dirty="0"/>
-              <a:t>Så har vi problem management. Et problem er årsagen, eller den mulige årsag, til en eller flere incidents. Problem management finder årsagen. Så det ikke sker igen.
- Der er tre faser. Først problem identification. Vi finder problemer i incidents, der kommer igen. Efter en major incident. Eller før, fx fra R&amp;D's tests. Så problem control. Vi finder root cause, altså grundårsagen. Og vi laver en workaround. Når vi kender årsagen, men ikke har løst den, hedder det en known error. Til sidst error control. Den rigtige løsning skal igennem change control, før den kommer ud.
- Eksemplet er en firmwareopdatering. Bagefter mister sensorerne på dyr på friland forbindelsen om natten. Det sker hos 15 kunder. Servicedesken genstarter gatewayen. Men de ser mønstret og opretter et problem. R&amp;D finder årsagen. Firmwaren går i strømsparetilstand og vågner ikke ved svagt signal. Workarounden er at slå strømspar fra. Fejlen bliver en known error, så alle bruger samme workaround. Og den rettede firmware kommer ud via change control.
- Så hvordan hænger de sammen? Incident management får servicen op igen. Problem management fjerner årsagen. En incident kan lukkes, selvom problemet stadig er åbent. Og når servicedesken kender en known error, løser de den næste incident hurtigere.</a:t>
+              <a:t>Men hvis den samme fejl bliver ved med at komme, er det ikke nok bare at genstarte. Så skal vi bruge problem management. Et problem er årsagen, eller den mulige årsag, til en eller flere incidents, og problem management finder den, så det ikke sker igen.
+ Det sker i tre faser. Først problem identification, hvor vi finder problemet. Det kan være i incidents, der kommer igen, efter en major incident, eller før, fx fra R&amp;D's tests. Så problem control, hvor vi finder root cause, altså grundårsagen, og laver en workaround. Når vi kender årsagen, men ikke har løst den, hedder det en known error. Og til sidst error control, hvor den rigtige løsning skal igennem change control, før den kommer ud.
+ Eksemplet i opgaven er en firmwareopdatering. Bagefter mister sensorerne på dyr på friland forbindelsen om natten, og det sker hos 15 kunder. Servicedesken genstarter gatewayen hver gang, men de ser mønstret og opretter et problem. R&amp;D finder så årsagen: firmwaren går i strømsparetilstand og vågner ikke ved svagt signal. Workarounden er at slå strømspar fra, og fejlen bliver registreret som en known error, så alle bruger den samme workaround. Den rettede firmware kommer så ud via change control.
+ Så hvordan hænger de to sammen? Incident management får servicen op igen, og problem management fjerner årsagen. En incident kan godt lukkes, selvom problemet stadig er åbent. Og når servicedesken kender en known error, kan de løse den næste incident hurtigere.</a:t>
             </a:r>
             <a:endParaRPr lang="en-US" dirty="0"/>
           </a:p>
@@ -955,12 +955,12 @@
           <a:p>
             <a:r>
               <a:rPr lang="en-US" dirty="0"/>
-              <a:t>Så kommer vi til de fire dimensioner. En service skal ses fra fire sider. Hvis man glemmer én, går det galt. Og så er der ting udefra, som påvirker dem alle. Det hedder PESTLE. Fx GDPR, NIS2 og krav om bæredygtighed.
- Først organisationer og mennesker. R&amp;D sidder i byen. Salg sidder på fabrikken. Så kan der nemt komme en os og dem-kultur. Green-IT skal have klare roller. Og man skal turde sige det, når noget går galt. Gerne tidligt.
- Så information og teknologi. Sensordata er kernen. Landmanden ejer sine data, og persondata er omfattet af GDPR. Og teknologien skal kunne vokse med de nye kontorer.
- Så partnere og leverandører. Det er fx hosting, sensorleverandører og teleselskaber. Når de er nede, er Green-IT også nede. Så de vigtige dele skal have failover. Altså en backup, der tager over.
- Og til sidst værdistrømme og processer. Værdistrømmen går på tværs af fabrikken og byen. Sagerne ligger og venter, når de skal fra det ene sted til det andet. Faste processer gør, at alle steder arbejder på samme måde.
-Og det var så min del. Og så vil jeg give ordet videre til Patrick.</a:t>
+              <a:t>Til sidst opgave 5, de fire dimensioner. De handler om, at det ikke er nok at have gode processer, for en service skal ses fra fire sider. Glemmer man én, går det galt. Og udenom ligger der ting udefra, som påvirker dem alle. Det hedder PESTLE, og for Green-IT er det fx GDPR, NIS2 og krav om bæredygtighed.
+ Den første er organisationer og mennesker. Her er Green-ITs udfordring, at R&amp;D sidder i byen og salg sidder på fabrikken. Så kan der nemt opstå en os og dem-kultur, hvor man ikke taler sammen. Derfor skal Green-IT have klare roller og en kultur, hvor man tør sige det tidligt, når noget går galt.
+ Den anden er information og teknologi. Sensordata er kernen i Green-ITs services, så det skal være klart, at landmanden ejer sine data, og at persondata er omfattet af GDPR. Og teknologien skal kunne vokse med, når de nye kontorer kommer.
+ Den tredje er partnere og leverandører, fx hosting, sensorleverandører og teleselskaber. Green-IT er afhængig af dem, for når de er nede, er Green-IT også nede. Derfor skal de vigtigste dele have failover, altså en backup, der tager over.
+ Den fjerde er værdistrømme og processer. Den hænger sammen med value chain fra opgave 3. Værdistrømmen går på tværs af fabrikken og byen, og det er, når sagerne skal fra det ene sted til det andet, at de ligger og venter. Faste processer sørger for, at alle steder arbejder på samme måde.
+Og det var så min del. Så vil jeg give ordet videre til Patrick.</a:t>
             </a:r>
             <a:endParaRPr lang="en-US" dirty="0"/>
           </a:p>

</xml_diff>